<commit_message>
Remove mobile number from Science Course PPTs and regenerate PDFs
</commit_message>
<xml_diff>
--- a/Science_Complete_Course_SagarSir/01_Physics_भौतिक_विज्ञान/Class_01_Motion_Speed_Force.pptx
+++ b/Science_Complete_Course_SagarSir/01_Physics_भौतिक_विज्ञान/Class_01_Motion_Speed_Force.pptx
@@ -3553,7 +3553,7 @@
               </a:defRPr>
             </a:pPr>
             <a:r>
-              <a:t>मार्गदर्शक: सागर सर (NMMS King)  |  Helpline / WhatsApp: +91 91101 13671  |  Website: sagarcoaching.tech</a:t>
+              <a:t>मार्गदर्शक: सागर सर (NMMS King)  |  Website: sagarcoaching.tech</a:t>
             </a:r>
           </a:p>
         </p:txBody>
@@ -3725,7 +3725,7 @@
               </a:defRPr>
             </a:pPr>
             <a:r>
-              <a:t>WhatsApp / Helpline: +91 91101 13671  |  वेबसाइट: sagarcoaching.tech  |  Slide 10 of 37</a:t>
+              <a:t>वेबसाइट: sagarcoaching.tech  |  Slide 10 of 37</a:t>
             </a:r>
           </a:p>
         </p:txBody>
@@ -4243,7 +4243,7 @@
               </a:defRPr>
             </a:pPr>
             <a:r>
-              <a:t>WhatsApp / Helpline: +91 91101 13671  |  वेबसाइट: sagarcoaching.tech  |  Slide 11 of 37</a:t>
+              <a:t>वेबसाइट: sagarcoaching.tech  |  Slide 11 of 37</a:t>
             </a:r>
           </a:p>
         </p:txBody>
@@ -4690,7 +4690,7 @@
               </a:defRPr>
             </a:pPr>
             <a:r>
-              <a:t>WhatsApp / Helpline: +91 91101 13671  |  वेबसाइट: sagarcoaching.tech  |  Slide 12 of 37</a:t>
+              <a:t>वेबसाइट: sagarcoaching.tech  |  Slide 12 of 37</a:t>
             </a:r>
           </a:p>
         </p:txBody>
@@ -5208,7 +5208,7 @@
               </a:defRPr>
             </a:pPr>
             <a:r>
-              <a:t>WhatsApp / Helpline: +91 91101 13671  |  वेबसाइट: sagarcoaching.tech  |  Slide 13 of 37</a:t>
+              <a:t>वेबसाइट: sagarcoaching.tech  |  Slide 13 of 37</a:t>
             </a:r>
           </a:p>
         </p:txBody>
@@ -5655,7 +5655,7 @@
               </a:defRPr>
             </a:pPr>
             <a:r>
-              <a:t>WhatsApp / Helpline: +91 91101 13671  |  वेबसाइट: sagarcoaching.tech  |  Slide 14 of 37</a:t>
+              <a:t>वेबसाइट: sagarcoaching.tech  |  Slide 14 of 37</a:t>
             </a:r>
           </a:p>
         </p:txBody>
@@ -6173,7 +6173,7 @@
               </a:defRPr>
             </a:pPr>
             <a:r>
-              <a:t>WhatsApp / Helpline: +91 91101 13671  |  वेबसाइट: sagarcoaching.tech  |  Slide 15 of 37</a:t>
+              <a:t>वेबसाइट: sagarcoaching.tech  |  Slide 15 of 37</a:t>
             </a:r>
           </a:p>
         </p:txBody>
@@ -6620,7 +6620,7 @@
               </a:defRPr>
             </a:pPr>
             <a:r>
-              <a:t>WhatsApp / Helpline: +91 91101 13671  |  वेबसाइट: sagarcoaching.tech  |  Slide 16 of 37</a:t>
+              <a:t>वेबसाइट: sagarcoaching.tech  |  Slide 16 of 37</a:t>
             </a:r>
           </a:p>
         </p:txBody>
@@ -7138,7 +7138,7 @@
               </a:defRPr>
             </a:pPr>
             <a:r>
-              <a:t>WhatsApp / Helpline: +91 91101 13671  |  वेबसाइट: sagarcoaching.tech  |  Slide 17 of 37</a:t>
+              <a:t>वेबसाइट: sagarcoaching.tech  |  Slide 17 of 37</a:t>
             </a:r>
           </a:p>
         </p:txBody>
@@ -7585,7 +7585,7 @@
               </a:defRPr>
             </a:pPr>
             <a:r>
-              <a:t>WhatsApp / Helpline: +91 91101 13671  |  वेबसाइट: sagarcoaching.tech  |  Slide 18 of 37</a:t>
+              <a:t>वेबसाइट: sagarcoaching.tech  |  Slide 18 of 37</a:t>
             </a:r>
           </a:p>
         </p:txBody>
@@ -8103,7 +8103,7 @@
               </a:defRPr>
             </a:pPr>
             <a:r>
-              <a:t>WhatsApp / Helpline: +91 91101 13671  |  वेबसाइट: sagarcoaching.tech  |  Slide 19 of 37</a:t>
+              <a:t>वेबसाइट: sagarcoaching.tech  |  Slide 19 of 37</a:t>
             </a:r>
           </a:p>
         </p:txBody>
@@ -8550,7 +8550,7 @@
               </a:defRPr>
             </a:pPr>
             <a:r>
-              <a:t>WhatsApp / Helpline: +91 91101 13671  |  वेबसाइट: sagarcoaching.tech  |  Slide 2 of 37</a:t>
+              <a:t>वेबसाइट: sagarcoaching.tech  |  Slide 2 of 37</a:t>
             </a:r>
           </a:p>
         </p:txBody>
@@ -8910,7 +8910,7 @@
               </a:defRPr>
             </a:pPr>
             <a:r>
-              <a:t>WhatsApp / Helpline: +91 91101 13671  |  वेबसाइट: sagarcoaching.tech  |  Slide 20 of 37</a:t>
+              <a:t>वेबसाइट: sagarcoaching.tech  |  Slide 20 of 37</a:t>
             </a:r>
           </a:p>
         </p:txBody>
@@ -9428,7 +9428,7 @@
               </a:defRPr>
             </a:pPr>
             <a:r>
-              <a:t>WhatsApp / Helpline: +91 91101 13671  |  वेबसाइट: sagarcoaching.tech  |  Slide 21 of 37</a:t>
+              <a:t>वेबसाइट: sagarcoaching.tech  |  Slide 21 of 37</a:t>
             </a:r>
           </a:p>
         </p:txBody>
@@ -9875,7 +9875,7 @@
               </a:defRPr>
             </a:pPr>
             <a:r>
-              <a:t>WhatsApp / Helpline: +91 91101 13671  |  वेबसाइट: sagarcoaching.tech  |  Slide 22 of 37</a:t>
+              <a:t>वेबसाइट: sagarcoaching.tech  |  Slide 22 of 37</a:t>
             </a:r>
           </a:p>
         </p:txBody>
@@ -10393,7 +10393,7 @@
               </a:defRPr>
             </a:pPr>
             <a:r>
-              <a:t>WhatsApp / Helpline: +91 91101 13671  |  वेबसाइट: sagarcoaching.tech  |  Slide 23 of 37</a:t>
+              <a:t>वेबसाइट: sagarcoaching.tech  |  Slide 23 of 37</a:t>
             </a:r>
           </a:p>
         </p:txBody>
@@ -10840,7 +10840,7 @@
               </a:defRPr>
             </a:pPr>
             <a:r>
-              <a:t>WhatsApp / Helpline: +91 91101 13671  |  वेबसाइट: sagarcoaching.tech  |  Slide 24 of 37</a:t>
+              <a:t>वेबसाइट: sagarcoaching.tech  |  Slide 24 of 37</a:t>
             </a:r>
           </a:p>
         </p:txBody>
@@ -11358,7 +11358,7 @@
               </a:defRPr>
             </a:pPr>
             <a:r>
-              <a:t>WhatsApp / Helpline: +91 91101 13671  |  वेबसाइट: sagarcoaching.tech  |  Slide 25 of 37</a:t>
+              <a:t>वेबसाइट: sagarcoaching.tech  |  Slide 25 of 37</a:t>
             </a:r>
           </a:p>
         </p:txBody>
@@ -11805,7 +11805,7 @@
               </a:defRPr>
             </a:pPr>
             <a:r>
-              <a:t>WhatsApp / Helpline: +91 91101 13671  |  वेबसाइट: sagarcoaching.tech  |  Slide 26 of 37</a:t>
+              <a:t>वेबसाइट: sagarcoaching.tech  |  Slide 26 of 37</a:t>
             </a:r>
           </a:p>
         </p:txBody>
@@ -12323,7 +12323,7 @@
               </a:defRPr>
             </a:pPr>
             <a:r>
-              <a:t>WhatsApp / Helpline: +91 91101 13671  |  वेबसाइट: sagarcoaching.tech  |  Slide 27 of 37</a:t>
+              <a:t>वेबसाइट: sagarcoaching.tech  |  Slide 27 of 37</a:t>
             </a:r>
           </a:p>
         </p:txBody>
@@ -12770,7 +12770,7 @@
               </a:defRPr>
             </a:pPr>
             <a:r>
-              <a:t>WhatsApp / Helpline: +91 91101 13671  |  वेबसाइट: sagarcoaching.tech  |  Slide 28 of 37</a:t>
+              <a:t>वेबसाइट: sagarcoaching.tech  |  Slide 28 of 37</a:t>
             </a:r>
           </a:p>
         </p:txBody>
@@ -13288,7 +13288,7 @@
               </a:defRPr>
             </a:pPr>
             <a:r>
-              <a:t>WhatsApp / Helpline: +91 91101 13671  |  वेबसाइट: sagarcoaching.tech  |  Slide 29 of 37</a:t>
+              <a:t>वेबसाइट: sagarcoaching.tech  |  Slide 29 of 37</a:t>
             </a:r>
           </a:p>
         </p:txBody>
@@ -13735,7 +13735,7 @@
               </a:defRPr>
             </a:pPr>
             <a:r>
-              <a:t>WhatsApp / Helpline: +91 91101 13671  |  वेबसाइट: sagarcoaching.tech  |  Slide 3 of 37</a:t>
+              <a:t>वेबसाइट: sagarcoaching.tech  |  Slide 3 of 37</a:t>
             </a:r>
           </a:p>
         </p:txBody>
@@ -14133,7 +14133,7 @@
               </a:defRPr>
             </a:pPr>
             <a:r>
-              <a:t>WhatsApp / Helpline: +91 91101 13671  |  वेबसाइट: sagarcoaching.tech  |  Slide 30 of 37</a:t>
+              <a:t>वेबसाइट: sagarcoaching.tech  |  Slide 30 of 37</a:t>
             </a:r>
           </a:p>
         </p:txBody>
@@ -14651,7 +14651,7 @@
               </a:defRPr>
             </a:pPr>
             <a:r>
-              <a:t>WhatsApp / Helpline: +91 91101 13671  |  वेबसाइट: sagarcoaching.tech  |  Slide 31 of 37</a:t>
+              <a:t>वेबसाइट: sagarcoaching.tech  |  Slide 31 of 37</a:t>
             </a:r>
           </a:p>
         </p:txBody>
@@ -15098,7 +15098,7 @@
               </a:defRPr>
             </a:pPr>
             <a:r>
-              <a:t>WhatsApp / Helpline: +91 91101 13671  |  वेबसाइट: sagarcoaching.tech  |  Slide 32 of 37</a:t>
+              <a:t>वेबसाइट: sagarcoaching.tech  |  Slide 32 of 37</a:t>
             </a:r>
           </a:p>
         </p:txBody>
@@ -15616,7 +15616,7 @@
               </a:defRPr>
             </a:pPr>
             <a:r>
-              <a:t>WhatsApp / Helpline: +91 91101 13671  |  वेबसाइट: sagarcoaching.tech  |  Slide 33 of 37</a:t>
+              <a:t>वेबसाइट: sagarcoaching.tech  |  Slide 33 of 37</a:t>
             </a:r>
           </a:p>
         </p:txBody>
@@ -16063,7 +16063,7 @@
               </a:defRPr>
             </a:pPr>
             <a:r>
-              <a:t>WhatsApp / Helpline: +91 91101 13671  |  वेबसाइट: sagarcoaching.tech  |  Slide 34 of 37</a:t>
+              <a:t>वेबसाइट: sagarcoaching.tech  |  Slide 34 of 37</a:t>
             </a:r>
           </a:p>
         </p:txBody>
@@ -16581,7 +16581,7 @@
               </a:defRPr>
             </a:pPr>
             <a:r>
-              <a:t>WhatsApp / Helpline: +91 91101 13671  |  वेबसाइट: sagarcoaching.tech  |  Slide 35 of 37</a:t>
+              <a:t>वेबसाइट: sagarcoaching.tech  |  Slide 35 of 37</a:t>
             </a:r>
           </a:p>
         </p:txBody>
@@ -16922,7 +16922,7 @@
               </a:defRPr>
             </a:pPr>
             <a:r>
-              <a:t>WhatsApp / Helpline: +91 91101 13671  |  वेबसाइट: sagarcoaching.tech  |  Slide 36 of 37</a:t>
+              <a:t>वेबसाइट: sagarcoaching.tech  |  Slide 36 of 37</a:t>
             </a:r>
           </a:p>
         </p:txBody>
@@ -17315,7 +17315,7 @@
               </a:defRPr>
             </a:pPr>
             <a:r>
-              <a:t>इस क्लास की PDF डाउनलोड करें: sagarcoaching.tech | Helpline: +91 91101 13671</a:t>
+              <a:t>इस क्लास की PDF डाउनलोड करें: sagarcoaching.tech</a:t>
             </a:r>
           </a:p>
         </p:txBody>
@@ -17470,7 +17470,7 @@
               </a:defRPr>
             </a:pPr>
             <a:r>
-              <a:t>मार्गदर्शक: सागर सर (NMMS King)  |  Helpline / WhatsApp: +91 91101 13671  |  Website: sagarcoaching.tech</a:t>
+              <a:t>मार्गदर्शक: सागर सर (NMMS King)  |  Website: sagarcoaching.tech</a:t>
             </a:r>
           </a:p>
         </p:txBody>
@@ -17642,7 +17642,7 @@
               </a:defRPr>
             </a:pPr>
             <a:r>
-              <a:t>WhatsApp / Helpline: +91 91101 13671  |  वेबसाइट: sagarcoaching.tech  |  Slide 4 of 37</a:t>
+              <a:t>वेबसाइट: sagarcoaching.tech  |  Slide 4 of 37</a:t>
             </a:r>
           </a:p>
         </p:txBody>
@@ -18021,7 +18021,7 @@
               </a:defRPr>
             </a:pPr>
             <a:r>
-              <a:t>WhatsApp / Helpline: +91 91101 13671  |  वेबसाइट: sagarcoaching.tech  |  Slide 5 of 37</a:t>
+              <a:t>वेबसाइट: sagarcoaching.tech  |  Slide 5 of 37</a:t>
             </a:r>
           </a:p>
         </p:txBody>
@@ -18468,7 +18468,7 @@
               </a:defRPr>
             </a:pPr>
             <a:r>
-              <a:t>WhatsApp / Helpline: +91 91101 13671  |  वेबसाइट: sagarcoaching.tech  |  Slide 6 of 37</a:t>
+              <a:t>वेबसाइट: sagarcoaching.tech  |  Slide 6 of 37</a:t>
             </a:r>
           </a:p>
         </p:txBody>
@@ -18986,7 +18986,7 @@
               </a:defRPr>
             </a:pPr>
             <a:r>
-              <a:t>WhatsApp / Helpline: +91 91101 13671  |  वेबसाइट: sagarcoaching.tech  |  Slide 7 of 37</a:t>
+              <a:t>वेबसाइट: sagarcoaching.tech  |  Slide 7 of 37</a:t>
             </a:r>
           </a:p>
         </p:txBody>
@@ -19433,7 +19433,7 @@
               </a:defRPr>
             </a:pPr>
             <a:r>
-              <a:t>WhatsApp / Helpline: +91 91101 13671  |  वेबसाइट: sagarcoaching.tech  |  Slide 8 of 37</a:t>
+              <a:t>वेबसाइट: sagarcoaching.tech  |  Slide 8 of 37</a:t>
             </a:r>
           </a:p>
         </p:txBody>
@@ -19951,7 +19951,7 @@
               </a:defRPr>
             </a:pPr>
             <a:r>
-              <a:t>WhatsApp / Helpline: +91 91101 13671  |  वेबसाइट: sagarcoaching.tech  |  Slide 9 of 37</a:t>
+              <a:t>वेबसाइट: sagarcoaching.tech  |  Slide 9 of 37</a:t>
             </a:r>
           </a:p>
         </p:txBody>

</xml_diff>